<commit_message>
Add Presentation (pptx and pdf)
</commit_message>
<xml_diff>
--- a/Presentation.pptx
+++ b/Presentation.pptx
@@ -7,7 +7,8 @@
   <p:sldIdLst>
     <p:sldId id="257" r:id="rId2"/>
     <p:sldId id="258" r:id="rId3"/>
-    <p:sldId id="259" r:id="rId4"/>
+    <p:sldId id="260" r:id="rId4"/>
+    <p:sldId id="259" r:id="rId5"/>
   </p:sldIdLst>
   <p:sldSz cx="18288000" cy="10287000"/>
   <p:notesSz cx="18288000" cy="10287000"/>
@@ -2604,13 +2605,342 @@
       </p:sp>
       <p:sp>
         <p:nvSpPr>
-          <p:cNvPr id="5" name="object 5"/>
+          <p:cNvPr id="7" name="object 7"/>
+          <p:cNvSpPr/>
+          <p:nvPr/>
+        </p:nvSpPr>
+        <p:spPr>
+          <a:xfrm>
+            <a:off x="-21465" y="6265097"/>
+            <a:ext cx="3652823" cy="4085877"/>
+          </a:xfrm>
+          <a:custGeom>
+            <a:avLst/>
+            <a:gdLst/>
+            <a:ahLst/>
+            <a:cxnLst/>
+            <a:rect l="l" t="t" r="r" b="b"/>
+            <a:pathLst>
+              <a:path w="3901440" h="4097654">
+                <a:moveTo>
+                  <a:pt x="91873" y="0"/>
+                </a:moveTo>
+                <a:lnTo>
+                  <a:pt x="104785" y="0"/>
+                </a:lnTo>
+                <a:lnTo>
+                  <a:pt x="111180" y="630"/>
+                </a:lnTo>
+                <a:lnTo>
+                  <a:pt x="147590" y="12999"/>
+                </a:lnTo>
+                <a:lnTo>
+                  <a:pt x="176499" y="38375"/>
+                </a:lnTo>
+                <a:lnTo>
+                  <a:pt x="193508" y="72896"/>
+                </a:lnTo>
+                <a:lnTo>
+                  <a:pt x="196657" y="91976"/>
+                </a:lnTo>
+                <a:lnTo>
+                  <a:pt x="196657" y="3917802"/>
+                </a:lnTo>
+                <a:lnTo>
+                  <a:pt x="3811242" y="3917806"/>
+                </a:lnTo>
+                <a:lnTo>
+                  <a:pt x="3848363" y="3927784"/>
+                </a:lnTo>
+                <a:lnTo>
+                  <a:pt x="3878848" y="3951222"/>
+                </a:lnTo>
+                <a:lnTo>
+                  <a:pt x="3898057" y="3984552"/>
+                </a:lnTo>
+                <a:lnTo>
+                  <a:pt x="3900933" y="3995801"/>
+                </a:lnTo>
+                <a:lnTo>
+                  <a:pt x="3900933" y="4036684"/>
+                </a:lnTo>
+                <a:lnTo>
+                  <a:pt x="3882903" y="4076314"/>
+                </a:lnTo>
+                <a:lnTo>
+                  <a:pt x="3860928" y="4097048"/>
+                </a:lnTo>
+                <a:lnTo>
+                  <a:pt x="42122" y="4097048"/>
+                </a:lnTo>
+                <a:lnTo>
+                  <a:pt x="12967" y="4065545"/>
+                </a:lnTo>
+                <a:lnTo>
+                  <a:pt x="628" y="4029109"/>
+                </a:lnTo>
+                <a:lnTo>
+                  <a:pt x="0" y="4022707"/>
+                </a:lnTo>
+                <a:lnTo>
+                  <a:pt x="1" y="91976"/>
+                </a:lnTo>
+                <a:lnTo>
+                  <a:pt x="9957" y="54796"/>
+                </a:lnTo>
+                <a:lnTo>
+                  <a:pt x="33366" y="24261"/>
+                </a:lnTo>
+                <a:lnTo>
+                  <a:pt x="66666" y="5019"/>
+                </a:lnTo>
+                <a:lnTo>
+                  <a:pt x="85478" y="630"/>
+                </a:lnTo>
+                <a:lnTo>
+                  <a:pt x="91873" y="0"/>
+                </a:lnTo>
+                <a:close/>
+              </a:path>
+            </a:pathLst>
+          </a:custGeom>
+          <a:solidFill>
+            <a:srgbClr val="1F618E"/>
+          </a:solidFill>
+        </p:spPr>
+        <p:txBody>
+          <a:bodyPr wrap="square" lIns="0" tIns="0" rIns="0" bIns="0" rtlCol="0"/>
+          <a:lstStyle/>
+          <a:p>
+            <a:endParaRPr/>
+          </a:p>
+        </p:txBody>
+      </p:sp>
+      <p:pic>
+        <p:nvPicPr>
+          <p:cNvPr id="10" name="Picture 9">
+            <a:extLst>
+              <a:ext uri="{FF2B5EF4-FFF2-40B4-BE49-F238E27FC236}">
+                <a16:creationId xmlns:a16="http://schemas.microsoft.com/office/drawing/2014/main" id="{0299D1FD-7514-CF74-EB38-4D8769821B0B}"/>
+              </a:ext>
+            </a:extLst>
+          </p:cNvPr>
+          <p:cNvPicPr>
+            <a:picLocks noChangeAspect="1"/>
+          </p:cNvPicPr>
+          <p:nvPr/>
+        </p:nvPicPr>
+        <p:blipFill>
+          <a:blip r:embed="rId2"/>
+          <a:stretch>
+            <a:fillRect/>
+          </a:stretch>
+        </p:blipFill>
+        <p:spPr>
+          <a:xfrm>
+            <a:off x="8001000" y="2189617"/>
+            <a:ext cx="7637517" cy="1786758"/>
+          </a:xfrm>
+          <a:prstGeom prst="rect">
+            <a:avLst/>
+          </a:prstGeom>
+        </p:spPr>
+      </p:pic>
+      <p:pic>
+        <p:nvPicPr>
+          <p:cNvPr id="12" name="Picture 11">
+            <a:extLst>
+              <a:ext uri="{FF2B5EF4-FFF2-40B4-BE49-F238E27FC236}">
+                <a16:creationId xmlns:a16="http://schemas.microsoft.com/office/drawing/2014/main" id="{CF54B2FF-D983-3A06-BDE7-955753CC66CD}"/>
+              </a:ext>
+            </a:extLst>
+          </p:cNvPr>
+          <p:cNvPicPr>
+            <a:picLocks noChangeAspect="1"/>
+          </p:cNvPicPr>
+          <p:nvPr/>
+        </p:nvPicPr>
+        <p:blipFill>
+          <a:blip r:embed="rId3"/>
+          <a:stretch>
+            <a:fillRect/>
+          </a:stretch>
+        </p:blipFill>
+        <p:spPr>
+          <a:xfrm>
+            <a:off x="8001000" y="6667500"/>
+            <a:ext cx="7620000" cy="2461172"/>
+          </a:xfrm>
+          <a:prstGeom prst="rect">
+            <a:avLst/>
+          </a:prstGeom>
+        </p:spPr>
+      </p:pic>
+      <p:pic>
+        <p:nvPicPr>
+          <p:cNvPr id="14" name="Picture 13">
+            <a:extLst>
+              <a:ext uri="{FF2B5EF4-FFF2-40B4-BE49-F238E27FC236}">
+                <a16:creationId xmlns:a16="http://schemas.microsoft.com/office/drawing/2014/main" id="{F47CB544-C62A-7544-4DC4-E48A8716CBB5}"/>
+              </a:ext>
+            </a:extLst>
+          </p:cNvPr>
+          <p:cNvPicPr>
+            <a:picLocks noChangeAspect="1"/>
+          </p:cNvPicPr>
+          <p:nvPr/>
+        </p:nvPicPr>
+        <p:blipFill>
+          <a:blip r:embed="rId4"/>
+          <a:stretch>
+            <a:fillRect/>
+          </a:stretch>
+        </p:blipFill>
+        <p:spPr>
+          <a:xfrm>
+            <a:off x="8001000" y="4000500"/>
+            <a:ext cx="7655034" cy="2662620"/>
+          </a:xfrm>
+          <a:prstGeom prst="rect">
+            <a:avLst/>
+          </a:prstGeom>
+        </p:spPr>
+      </p:pic>
+      <p:pic>
+        <p:nvPicPr>
+          <p:cNvPr id="16" name="Picture 15">
+            <a:extLst>
+              <a:ext uri="{FF2B5EF4-FFF2-40B4-BE49-F238E27FC236}">
+                <a16:creationId xmlns:a16="http://schemas.microsoft.com/office/drawing/2014/main" id="{9201238F-4862-DA13-45BC-6015D59470A0}"/>
+              </a:ext>
+            </a:extLst>
+          </p:cNvPr>
+          <p:cNvPicPr>
+            <a:picLocks noChangeAspect="1"/>
+          </p:cNvPicPr>
+          <p:nvPr/>
+        </p:nvPicPr>
+        <p:blipFill>
+          <a:blip r:embed="rId5"/>
+          <a:stretch>
+            <a:fillRect/>
+          </a:stretch>
+        </p:blipFill>
+        <p:spPr>
+          <a:xfrm rot="16200000">
+            <a:off x="13011915" y="5372858"/>
+            <a:ext cx="7485211" cy="476158"/>
+          </a:xfrm>
+          <a:prstGeom prst="rect">
+            <a:avLst/>
+          </a:prstGeom>
+        </p:spPr>
+      </p:pic>
+      <p:pic>
+        <p:nvPicPr>
+          <p:cNvPr id="18" name="Picture 17">
+            <a:extLst>
+              <a:ext uri="{FF2B5EF4-FFF2-40B4-BE49-F238E27FC236}">
+                <a16:creationId xmlns:a16="http://schemas.microsoft.com/office/drawing/2014/main" id="{3EA05C8C-C298-706B-5EA0-2D3E4F4CF985}"/>
+              </a:ext>
+            </a:extLst>
+          </p:cNvPr>
+          <p:cNvPicPr>
+            <a:picLocks noChangeAspect="1"/>
+          </p:cNvPicPr>
+          <p:nvPr/>
+        </p:nvPicPr>
+        <p:blipFill>
+          <a:blip r:embed="rId6"/>
+          <a:stretch>
+            <a:fillRect/>
+          </a:stretch>
+        </p:blipFill>
+        <p:spPr>
+          <a:xfrm>
+            <a:off x="962025" y="2603592"/>
+            <a:ext cx="6429375" cy="1981200"/>
+          </a:xfrm>
+          <a:prstGeom prst="rect">
+            <a:avLst/>
+          </a:prstGeom>
+        </p:spPr>
+      </p:pic>
+      <p:pic>
+        <p:nvPicPr>
+          <p:cNvPr id="20" name="Picture 19">
+            <a:extLst>
+              <a:ext uri="{FF2B5EF4-FFF2-40B4-BE49-F238E27FC236}">
+                <a16:creationId xmlns:a16="http://schemas.microsoft.com/office/drawing/2014/main" id="{3925904D-103A-C11E-9672-CCB04E9F3E4E}"/>
+              </a:ext>
+            </a:extLst>
+          </p:cNvPr>
+          <p:cNvPicPr>
+            <a:picLocks noChangeAspect="1"/>
+          </p:cNvPicPr>
+          <p:nvPr/>
+        </p:nvPicPr>
+        <p:blipFill>
+          <a:blip r:embed="rId7"/>
+          <a:stretch>
+            <a:fillRect/>
+          </a:stretch>
+        </p:blipFill>
+        <p:spPr>
+          <a:xfrm>
+            <a:off x="942975" y="4610100"/>
+            <a:ext cx="6448425" cy="3619500"/>
+          </a:xfrm>
+          <a:prstGeom prst="rect">
+            <a:avLst/>
+          </a:prstGeom>
+        </p:spPr>
+      </p:pic>
+      <p:pic>
+        <p:nvPicPr>
+          <p:cNvPr id="22" name="Picture 21">
+            <a:extLst>
+              <a:ext uri="{FF2B5EF4-FFF2-40B4-BE49-F238E27FC236}">
+                <a16:creationId xmlns:a16="http://schemas.microsoft.com/office/drawing/2014/main" id="{C7E83527-7E88-2B7B-0A73-AFFAF04FA204}"/>
+              </a:ext>
+            </a:extLst>
+          </p:cNvPr>
+          <p:cNvPicPr>
+            <a:picLocks noChangeAspect="1"/>
+          </p:cNvPicPr>
+          <p:nvPr/>
+        </p:nvPicPr>
+        <p:blipFill>
+          <a:blip r:embed="rId8"/>
+          <a:stretch>
+            <a:fillRect/>
+          </a:stretch>
+        </p:blipFill>
+        <p:spPr>
+          <a:xfrm>
+            <a:off x="1066800" y="8267700"/>
+            <a:ext cx="6400800" cy="1781175"/>
+          </a:xfrm>
+          <a:prstGeom prst="rect">
+            <a:avLst/>
+          </a:prstGeom>
+        </p:spPr>
+      </p:pic>
+      <p:sp>
+        <p:nvSpPr>
+          <p:cNvPr id="23" name="object 5">
+            <a:extLst>
+              <a:ext uri="{FF2B5EF4-FFF2-40B4-BE49-F238E27FC236}">
+                <a16:creationId xmlns:a16="http://schemas.microsoft.com/office/drawing/2014/main" id="{314E5453-E4AD-08FC-2C46-FACA32ADB826}"/>
+              </a:ext>
+            </a:extLst>
+          </p:cNvPr>
           <p:cNvSpPr txBox="1"/>
           <p:nvPr/>
         </p:nvSpPr>
         <p:spPr>
           <a:xfrm>
-            <a:off x="6172200" y="1028700"/>
+            <a:off x="5277757" y="1100458"/>
             <a:ext cx="7732485" cy="635000"/>
           </a:xfrm>
           <a:prstGeom prst="rect">
@@ -2659,125 +2989,12 @@
                 <a:latin typeface="Cambria"/>
                 <a:cs typeface="Cambria"/>
               </a:rPr>
-              <a:t> Flows</a:t>
+              <a:t> Flows – Theory </a:t>
             </a:r>
             <a:endParaRPr sz="4000" dirty="0">
               <a:latin typeface="Cambria"/>
               <a:cs typeface="Cambria"/>
             </a:endParaRPr>
-          </a:p>
-        </p:txBody>
-      </p:sp>
-      <p:sp>
-        <p:nvSpPr>
-          <p:cNvPr id="7" name="object 7"/>
-          <p:cNvSpPr/>
-          <p:nvPr/>
-        </p:nvSpPr>
-        <p:spPr>
-          <a:xfrm>
-            <a:off x="-21465" y="6265097"/>
-            <a:ext cx="3652823" cy="4085877"/>
-          </a:xfrm>
-          <a:custGeom>
-            <a:avLst/>
-            <a:gdLst/>
-            <a:ahLst/>
-            <a:cxnLst/>
-            <a:rect l="l" t="t" r="r" b="b"/>
-            <a:pathLst>
-              <a:path w="3901440" h="4097654">
-                <a:moveTo>
-                  <a:pt x="91873" y="0"/>
-                </a:moveTo>
-                <a:lnTo>
-                  <a:pt x="104785" y="0"/>
-                </a:lnTo>
-                <a:lnTo>
-                  <a:pt x="111180" y="630"/>
-                </a:lnTo>
-                <a:lnTo>
-                  <a:pt x="147590" y="12999"/>
-                </a:lnTo>
-                <a:lnTo>
-                  <a:pt x="176499" y="38375"/>
-                </a:lnTo>
-                <a:lnTo>
-                  <a:pt x="193508" y="72896"/>
-                </a:lnTo>
-                <a:lnTo>
-                  <a:pt x="196657" y="91976"/>
-                </a:lnTo>
-                <a:lnTo>
-                  <a:pt x="196657" y="3917802"/>
-                </a:lnTo>
-                <a:lnTo>
-                  <a:pt x="3811242" y="3917806"/>
-                </a:lnTo>
-                <a:lnTo>
-                  <a:pt x="3848363" y="3927784"/>
-                </a:lnTo>
-                <a:lnTo>
-                  <a:pt x="3878848" y="3951222"/>
-                </a:lnTo>
-                <a:lnTo>
-                  <a:pt x="3898057" y="3984552"/>
-                </a:lnTo>
-                <a:lnTo>
-                  <a:pt x="3900933" y="3995801"/>
-                </a:lnTo>
-                <a:lnTo>
-                  <a:pt x="3900933" y="4036684"/>
-                </a:lnTo>
-                <a:lnTo>
-                  <a:pt x="3882903" y="4076314"/>
-                </a:lnTo>
-                <a:lnTo>
-                  <a:pt x="3860928" y="4097048"/>
-                </a:lnTo>
-                <a:lnTo>
-                  <a:pt x="42122" y="4097048"/>
-                </a:lnTo>
-                <a:lnTo>
-                  <a:pt x="12967" y="4065545"/>
-                </a:lnTo>
-                <a:lnTo>
-                  <a:pt x="628" y="4029109"/>
-                </a:lnTo>
-                <a:lnTo>
-                  <a:pt x="0" y="4022707"/>
-                </a:lnTo>
-                <a:lnTo>
-                  <a:pt x="1" y="91976"/>
-                </a:lnTo>
-                <a:lnTo>
-                  <a:pt x="9957" y="54796"/>
-                </a:lnTo>
-                <a:lnTo>
-                  <a:pt x="33366" y="24261"/>
-                </a:lnTo>
-                <a:lnTo>
-                  <a:pt x="66666" y="5019"/>
-                </a:lnTo>
-                <a:lnTo>
-                  <a:pt x="85478" y="630"/>
-                </a:lnTo>
-                <a:lnTo>
-                  <a:pt x="91873" y="0"/>
-                </a:lnTo>
-                <a:close/>
-              </a:path>
-            </a:pathLst>
-          </a:custGeom>
-          <a:solidFill>
-            <a:srgbClr val="1F618E"/>
-          </a:solidFill>
-        </p:spPr>
-        <p:txBody>
-          <a:bodyPr wrap="square" lIns="0" tIns="0" rIns="0" bIns="0" rtlCol="0"/>
-          <a:lstStyle/>
-          <a:p>
-            <a:endParaRPr/>
           </a:p>
         </p:txBody>
       </p:sp>
@@ -2865,6 +3082,291 @@
         </p:nvSpPr>
         <p:spPr>
           <a:xfrm>
+            <a:off x="5277757" y="1100458"/>
+            <a:ext cx="7732485" cy="635000"/>
+          </a:xfrm>
+          <a:prstGeom prst="rect">
+            <a:avLst/>
+          </a:prstGeom>
+        </p:spPr>
+        <p:txBody>
+          <a:bodyPr vert="horz" wrap="square" lIns="0" tIns="12700" rIns="0" bIns="0" rtlCol="0">
+            <a:spAutoFit/>
+          </a:bodyPr>
+          <a:lstStyle/>
+          <a:p>
+            <a:pPr marL="12700">
+              <a:lnSpc>
+                <a:spcPct val="100000"/>
+              </a:lnSpc>
+              <a:spcBef>
+                <a:spcPts val="100"/>
+              </a:spcBef>
+            </a:pPr>
+            <a:r>
+              <a:rPr lang="en-US" sz="4000" dirty="0">
+                <a:solidFill>
+                  <a:srgbClr val="463125"/>
+                </a:solidFill>
+                <a:latin typeface="Cambria"/>
+                <a:cs typeface="Cambria"/>
+              </a:rPr>
+              <a:t>Part 1: </a:t>
+            </a:r>
+            <a:r>
+              <a:rPr lang="en-US" sz="4000" dirty="0" err="1">
+                <a:solidFill>
+                  <a:srgbClr val="463125"/>
+                </a:solidFill>
+                <a:latin typeface="Cambria"/>
+                <a:cs typeface="Cambria"/>
+              </a:rPr>
+              <a:t>Normalising</a:t>
+            </a:r>
+            <a:r>
+              <a:rPr lang="en-US" sz="4000" dirty="0">
+                <a:solidFill>
+                  <a:srgbClr val="463125"/>
+                </a:solidFill>
+                <a:latin typeface="Cambria"/>
+                <a:cs typeface="Cambria"/>
+              </a:rPr>
+              <a:t> Flows – Results </a:t>
+            </a:r>
+            <a:endParaRPr sz="4000" dirty="0">
+              <a:latin typeface="Cambria"/>
+              <a:cs typeface="Cambria"/>
+            </a:endParaRPr>
+          </a:p>
+        </p:txBody>
+      </p:sp>
+      <p:sp>
+        <p:nvSpPr>
+          <p:cNvPr id="7" name="object 7"/>
+          <p:cNvSpPr/>
+          <p:nvPr/>
+        </p:nvSpPr>
+        <p:spPr>
+          <a:xfrm>
+            <a:off x="-21465" y="6265097"/>
+            <a:ext cx="3652823" cy="4085877"/>
+          </a:xfrm>
+          <a:custGeom>
+            <a:avLst/>
+            <a:gdLst/>
+            <a:ahLst/>
+            <a:cxnLst/>
+            <a:rect l="l" t="t" r="r" b="b"/>
+            <a:pathLst>
+              <a:path w="3901440" h="4097654">
+                <a:moveTo>
+                  <a:pt x="91873" y="0"/>
+                </a:moveTo>
+                <a:lnTo>
+                  <a:pt x="104785" y="0"/>
+                </a:lnTo>
+                <a:lnTo>
+                  <a:pt x="111180" y="630"/>
+                </a:lnTo>
+                <a:lnTo>
+                  <a:pt x="147590" y="12999"/>
+                </a:lnTo>
+                <a:lnTo>
+                  <a:pt x="176499" y="38375"/>
+                </a:lnTo>
+                <a:lnTo>
+                  <a:pt x="193508" y="72896"/>
+                </a:lnTo>
+                <a:lnTo>
+                  <a:pt x="196657" y="91976"/>
+                </a:lnTo>
+                <a:lnTo>
+                  <a:pt x="196657" y="3917802"/>
+                </a:lnTo>
+                <a:lnTo>
+                  <a:pt x="3811242" y="3917806"/>
+                </a:lnTo>
+                <a:lnTo>
+                  <a:pt x="3848363" y="3927784"/>
+                </a:lnTo>
+                <a:lnTo>
+                  <a:pt x="3878848" y="3951222"/>
+                </a:lnTo>
+                <a:lnTo>
+                  <a:pt x="3898057" y="3984552"/>
+                </a:lnTo>
+                <a:lnTo>
+                  <a:pt x="3900933" y="3995801"/>
+                </a:lnTo>
+                <a:lnTo>
+                  <a:pt x="3900933" y="4036684"/>
+                </a:lnTo>
+                <a:lnTo>
+                  <a:pt x="3882903" y="4076314"/>
+                </a:lnTo>
+                <a:lnTo>
+                  <a:pt x="3860928" y="4097048"/>
+                </a:lnTo>
+                <a:lnTo>
+                  <a:pt x="42122" y="4097048"/>
+                </a:lnTo>
+                <a:lnTo>
+                  <a:pt x="12967" y="4065545"/>
+                </a:lnTo>
+                <a:lnTo>
+                  <a:pt x="628" y="4029109"/>
+                </a:lnTo>
+                <a:lnTo>
+                  <a:pt x="0" y="4022707"/>
+                </a:lnTo>
+                <a:lnTo>
+                  <a:pt x="1" y="91976"/>
+                </a:lnTo>
+                <a:lnTo>
+                  <a:pt x="9957" y="54796"/>
+                </a:lnTo>
+                <a:lnTo>
+                  <a:pt x="33366" y="24261"/>
+                </a:lnTo>
+                <a:lnTo>
+                  <a:pt x="66666" y="5019"/>
+                </a:lnTo>
+                <a:lnTo>
+                  <a:pt x="85478" y="630"/>
+                </a:lnTo>
+                <a:lnTo>
+                  <a:pt x="91873" y="0"/>
+                </a:lnTo>
+                <a:close/>
+              </a:path>
+            </a:pathLst>
+          </a:custGeom>
+          <a:solidFill>
+            <a:srgbClr val="1F618E"/>
+          </a:solidFill>
+        </p:spPr>
+        <p:txBody>
+          <a:bodyPr wrap="square" lIns="0" tIns="0" rIns="0" bIns="0" rtlCol="0"/>
+          <a:lstStyle/>
+          <a:p>
+            <a:endParaRPr/>
+          </a:p>
+        </p:txBody>
+      </p:sp>
+      <p:pic>
+        <p:nvPicPr>
+          <p:cNvPr id="3" name="Picture 2">
+            <a:extLst>
+              <a:ext uri="{FF2B5EF4-FFF2-40B4-BE49-F238E27FC236}">
+                <a16:creationId xmlns:a16="http://schemas.microsoft.com/office/drawing/2014/main" id="{C95402DD-5B41-6F7F-0001-95FB9D10B8FC}"/>
+              </a:ext>
+            </a:extLst>
+          </p:cNvPr>
+          <p:cNvPicPr>
+            <a:picLocks noChangeAspect="1"/>
+          </p:cNvPicPr>
+          <p:nvPr/>
+        </p:nvPicPr>
+        <p:blipFill>
+          <a:blip r:embed="rId2"/>
+          <a:stretch>
+            <a:fillRect/>
+          </a:stretch>
+        </p:blipFill>
+        <p:spPr>
+          <a:xfrm>
+            <a:off x="2362200" y="2171700"/>
+            <a:ext cx="13563600" cy="6545226"/>
+          </a:xfrm>
+          <a:prstGeom prst="rect">
+            <a:avLst/>
+          </a:prstGeom>
+        </p:spPr>
+      </p:pic>
+    </p:spTree>
+    <p:extLst>
+      <p:ext uri="{BB962C8B-B14F-4D97-AF65-F5344CB8AC3E}">
+        <p14:creationId xmlns:p14="http://schemas.microsoft.com/office/powerpoint/2010/main" val="2641252081"/>
+      </p:ext>
+    </p:extLst>
+  </p:cSld>
+  <p:clrMapOvr>
+    <a:masterClrMapping/>
+  </p:clrMapOvr>
+</p:sld>
+</file>
+
+<file path=ppt/slides/slide4.xml><?xml version="1.0" encoding="utf-8"?>
+<p:sld xmlns:a="http://schemas.openxmlformats.org/drawingml/2006/main" xmlns:r="http://schemas.openxmlformats.org/officeDocument/2006/relationships" xmlns:p="http://schemas.openxmlformats.org/presentationml/2006/main">
+  <p:cSld>
+    <p:spTree>
+      <p:nvGrpSpPr>
+        <p:cNvPr id="1" name=""/>
+        <p:cNvGrpSpPr/>
+        <p:nvPr/>
+      </p:nvGrpSpPr>
+      <p:grpSpPr>
+        <a:xfrm>
+          <a:off x="0" y="0"/>
+          <a:ext cx="0" cy="0"/>
+          <a:chOff x="0" y="0"/>
+          <a:chExt cx="0" cy="0"/>
+        </a:xfrm>
+      </p:grpSpPr>
+      <p:sp>
+        <p:nvSpPr>
+          <p:cNvPr id="4" name="object 4"/>
+          <p:cNvSpPr txBox="1"/>
+          <p:nvPr/>
+        </p:nvSpPr>
+        <p:spPr>
+          <a:xfrm>
+            <a:off x="8473134" y="9589410"/>
+            <a:ext cx="1341755" cy="265430"/>
+          </a:xfrm>
+          <a:prstGeom prst="rect">
+            <a:avLst/>
+          </a:prstGeom>
+        </p:spPr>
+        <p:txBody>
+          <a:bodyPr vert="horz" wrap="square" lIns="0" tIns="15875" rIns="0" bIns="0" rtlCol="0">
+            <a:spAutoFit/>
+          </a:bodyPr>
+          <a:lstStyle/>
+          <a:p>
+            <a:pPr marL="12700">
+              <a:lnSpc>
+                <a:spcPct val="100000"/>
+              </a:lnSpc>
+              <a:spcBef>
+                <a:spcPts val="125"/>
+              </a:spcBef>
+            </a:pPr>
+            <a:r>
+              <a:rPr sz="1550" spc="270" dirty="0">
+                <a:solidFill>
+                  <a:srgbClr val="463125"/>
+                </a:solidFill>
+                <a:latin typeface="Calibri"/>
+                <a:cs typeface="Calibri"/>
+              </a:rPr>
+              <a:t>02/02/2023</a:t>
+            </a:r>
+            <a:endParaRPr sz="1550" dirty="0">
+              <a:latin typeface="Calibri"/>
+              <a:cs typeface="Calibri"/>
+            </a:endParaRPr>
+          </a:p>
+        </p:txBody>
+      </p:sp>
+      <p:sp>
+        <p:nvSpPr>
+          <p:cNvPr id="5" name="object 5"/>
+          <p:cNvSpPr txBox="1"/>
+          <p:nvPr/>
+        </p:nvSpPr>
+        <p:spPr>
+          <a:xfrm>
             <a:off x="3924300" y="1028700"/>
             <a:ext cx="10439400" cy="628377"/>
           </a:xfrm>
@@ -3016,6 +3518,375 @@
           </a:p>
         </p:txBody>
       </p:sp>
+      <p:grpSp>
+        <p:nvGrpSpPr>
+          <p:cNvPr id="20" name="Group 19">
+            <a:extLst>
+              <a:ext uri="{FF2B5EF4-FFF2-40B4-BE49-F238E27FC236}">
+                <a16:creationId xmlns:a16="http://schemas.microsoft.com/office/drawing/2014/main" id="{888E53F8-E3EE-72D6-5ED6-C1A76A78E720}"/>
+              </a:ext>
+            </a:extLst>
+          </p:cNvPr>
+          <p:cNvGrpSpPr/>
+          <p:nvPr/>
+        </p:nvGrpSpPr>
+        <p:grpSpPr>
+          <a:xfrm>
+            <a:off x="889059" y="5384016"/>
+            <a:ext cx="8254941" cy="3217306"/>
+            <a:chOff x="854728" y="5510792"/>
+            <a:chExt cx="8047008" cy="2787424"/>
+          </a:xfrm>
+        </p:grpSpPr>
+        <p:pic>
+          <p:nvPicPr>
+            <p:cNvPr id="8" name="Picture 7" descr="A picture containing text, monitor, electronics, display&#10;&#10;Description automatically generated">
+              <a:extLst>
+                <a:ext uri="{FF2B5EF4-FFF2-40B4-BE49-F238E27FC236}">
+                  <a16:creationId xmlns:a16="http://schemas.microsoft.com/office/drawing/2014/main" id="{0B980F02-3EA4-541E-F69C-DFA96AEDE505}"/>
+                </a:ext>
+              </a:extLst>
+            </p:cNvPr>
+            <p:cNvPicPr>
+              <a:picLocks noChangeAspect="1"/>
+            </p:cNvPicPr>
+            <p:nvPr/>
+          </p:nvPicPr>
+          <p:blipFill>
+            <a:blip r:embed="rId2">
+              <a:extLst>
+                <a:ext uri="{28A0092B-C50C-407E-A947-70E740481C1C}">
+                  <a14:useLocalDpi xmlns:a14="http://schemas.microsoft.com/office/drawing/2010/main" val="0"/>
+                </a:ext>
+              </a:extLst>
+            </a:blip>
+            <a:stretch>
+              <a:fillRect/>
+            </a:stretch>
+          </p:blipFill>
+          <p:spPr>
+            <a:xfrm>
+              <a:off x="854728" y="5510792"/>
+              <a:ext cx="8047008" cy="2682336"/>
+            </a:xfrm>
+            <a:prstGeom prst="rect">
+              <a:avLst/>
+            </a:prstGeom>
+          </p:spPr>
+        </p:pic>
+        <p:sp>
+          <p:nvSpPr>
+            <p:cNvPr id="11" name="TextBox 10">
+              <a:extLst>
+                <a:ext uri="{FF2B5EF4-FFF2-40B4-BE49-F238E27FC236}">
+                  <a16:creationId xmlns:a16="http://schemas.microsoft.com/office/drawing/2014/main" id="{27AF72B4-D39E-5116-ED63-96603F22D425}"/>
+                </a:ext>
+              </a:extLst>
+            </p:cNvPr>
+            <p:cNvSpPr txBox="1"/>
+            <p:nvPr/>
+          </p:nvSpPr>
+          <p:spPr>
+            <a:xfrm>
+              <a:off x="4225834" y="7928884"/>
+              <a:ext cx="3652823" cy="369332"/>
+            </a:xfrm>
+            <a:prstGeom prst="rect">
+              <a:avLst/>
+            </a:prstGeom>
+            <a:noFill/>
+          </p:spPr>
+          <p:txBody>
+            <a:bodyPr wrap="square" rtlCol="0">
+              <a:spAutoFit/>
+            </a:bodyPr>
+            <a:lstStyle/>
+            <a:p>
+              <a:r>
+                <a:rPr lang="en-US" dirty="0"/>
+                <a:t>01-01-2016</a:t>
+              </a:r>
+              <a:endParaRPr lang="en-DE" dirty="0"/>
+            </a:p>
+          </p:txBody>
+        </p:sp>
+      </p:grpSp>
+      <p:grpSp>
+        <p:nvGrpSpPr>
+          <p:cNvPr id="21" name="Group 20">
+            <a:extLst>
+              <a:ext uri="{FF2B5EF4-FFF2-40B4-BE49-F238E27FC236}">
+                <a16:creationId xmlns:a16="http://schemas.microsoft.com/office/drawing/2014/main" id="{11EAD243-9413-21C7-C2FD-A955AAF0B7C9}"/>
+              </a:ext>
+            </a:extLst>
+          </p:cNvPr>
+          <p:cNvGrpSpPr/>
+          <p:nvPr/>
+        </p:nvGrpSpPr>
+        <p:grpSpPr>
+          <a:xfrm>
+            <a:off x="8794940" y="2240288"/>
+            <a:ext cx="9143143" cy="3078159"/>
+            <a:chOff x="8799294" y="2226745"/>
+            <a:chExt cx="9143143" cy="3078159"/>
+          </a:xfrm>
+        </p:grpSpPr>
+        <p:pic>
+          <p:nvPicPr>
+            <p:cNvPr id="3" name="Picture 2">
+              <a:extLst>
+                <a:ext uri="{FF2B5EF4-FFF2-40B4-BE49-F238E27FC236}">
+                  <a16:creationId xmlns:a16="http://schemas.microsoft.com/office/drawing/2014/main" id="{959A7F95-D611-8D4D-F6C1-5776FF585BD3}"/>
+                </a:ext>
+              </a:extLst>
+            </p:cNvPr>
+            <p:cNvPicPr>
+              <a:picLocks noChangeAspect="1"/>
+            </p:cNvPicPr>
+            <p:nvPr/>
+          </p:nvPicPr>
+          <p:blipFill>
+            <a:blip r:embed="rId3">
+              <a:extLst>
+                <a:ext uri="{28A0092B-C50C-407E-A947-70E740481C1C}">
+                  <a14:useLocalDpi xmlns:a14="http://schemas.microsoft.com/office/drawing/2010/main" val="0"/>
+                </a:ext>
+              </a:extLst>
+            </a:blip>
+            <a:stretch>
+              <a:fillRect/>
+            </a:stretch>
+          </p:blipFill>
+          <p:spPr>
+            <a:xfrm>
+              <a:off x="8799294" y="2226745"/>
+              <a:ext cx="9143143" cy="3047714"/>
+            </a:xfrm>
+            <a:prstGeom prst="rect">
+              <a:avLst/>
+            </a:prstGeom>
+          </p:spPr>
+        </p:pic>
+        <p:sp>
+          <p:nvSpPr>
+            <p:cNvPr id="12" name="TextBox 11">
+              <a:extLst>
+                <a:ext uri="{FF2B5EF4-FFF2-40B4-BE49-F238E27FC236}">
+                  <a16:creationId xmlns:a16="http://schemas.microsoft.com/office/drawing/2014/main" id="{FBABB7DE-CCA6-7CB0-E8DA-0B52296D321F}"/>
+                </a:ext>
+              </a:extLst>
+            </p:cNvPr>
+            <p:cNvSpPr txBox="1"/>
+            <p:nvPr/>
+          </p:nvSpPr>
+          <p:spPr>
+            <a:xfrm>
+              <a:off x="12725400" y="4935572"/>
+              <a:ext cx="3652823" cy="369332"/>
+            </a:xfrm>
+            <a:prstGeom prst="rect">
+              <a:avLst/>
+            </a:prstGeom>
+            <a:noFill/>
+          </p:spPr>
+          <p:txBody>
+            <a:bodyPr wrap="square" rtlCol="0">
+              <a:spAutoFit/>
+            </a:bodyPr>
+            <a:lstStyle/>
+            <a:p>
+              <a:r>
+                <a:rPr lang="en-US" dirty="0"/>
+                <a:t>01-01-2012</a:t>
+              </a:r>
+              <a:endParaRPr lang="en-DE" dirty="0"/>
+            </a:p>
+          </p:txBody>
+        </p:sp>
+      </p:grpSp>
+      <p:grpSp>
+        <p:nvGrpSpPr>
+          <p:cNvPr id="22" name="Group 21">
+            <a:extLst>
+              <a:ext uri="{FF2B5EF4-FFF2-40B4-BE49-F238E27FC236}">
+                <a16:creationId xmlns:a16="http://schemas.microsoft.com/office/drawing/2014/main" id="{F9C9CDCC-91D5-A8B0-F7F6-D6D22B1CE449}"/>
+              </a:ext>
+            </a:extLst>
+          </p:cNvPr>
+          <p:cNvGrpSpPr/>
+          <p:nvPr/>
+        </p:nvGrpSpPr>
+        <p:grpSpPr>
+          <a:xfrm>
+            <a:off x="8794940" y="5382562"/>
+            <a:ext cx="9372600" cy="3136378"/>
+            <a:chOff x="8763000" y="5844127"/>
+            <a:chExt cx="9372600" cy="3136378"/>
+          </a:xfrm>
+        </p:grpSpPr>
+        <p:pic>
+          <p:nvPicPr>
+            <p:cNvPr id="10" name="Picture 9">
+              <a:extLst>
+                <a:ext uri="{FF2B5EF4-FFF2-40B4-BE49-F238E27FC236}">
+                  <a16:creationId xmlns:a16="http://schemas.microsoft.com/office/drawing/2014/main" id="{60EFD716-D804-E9E9-2008-15C3B34B41EC}"/>
+                </a:ext>
+              </a:extLst>
+            </p:cNvPr>
+            <p:cNvPicPr>
+              <a:picLocks noChangeAspect="1"/>
+            </p:cNvPicPr>
+            <p:nvPr/>
+          </p:nvPicPr>
+          <p:blipFill>
+            <a:blip r:embed="rId4">
+              <a:extLst>
+                <a:ext uri="{28A0092B-C50C-407E-A947-70E740481C1C}">
+                  <a14:useLocalDpi xmlns:a14="http://schemas.microsoft.com/office/drawing/2010/main" val="0"/>
+                </a:ext>
+              </a:extLst>
+            </a:blip>
+            <a:stretch>
+              <a:fillRect/>
+            </a:stretch>
+          </p:blipFill>
+          <p:spPr>
+            <a:xfrm>
+              <a:off x="8763000" y="5844127"/>
+              <a:ext cx="9372600" cy="3124200"/>
+            </a:xfrm>
+            <a:prstGeom prst="rect">
+              <a:avLst/>
+            </a:prstGeom>
+          </p:spPr>
+        </p:pic>
+        <p:sp>
+          <p:nvSpPr>
+            <p:cNvPr id="13" name="TextBox 12">
+              <a:extLst>
+                <a:ext uri="{FF2B5EF4-FFF2-40B4-BE49-F238E27FC236}">
+                  <a16:creationId xmlns:a16="http://schemas.microsoft.com/office/drawing/2014/main" id="{E18DED26-9821-8ACE-6635-7D586DE448A5}"/>
+                </a:ext>
+              </a:extLst>
+            </p:cNvPr>
+            <p:cNvSpPr txBox="1"/>
+            <p:nvPr/>
+          </p:nvSpPr>
+          <p:spPr>
+            <a:xfrm>
+              <a:off x="12801600" y="8611173"/>
+              <a:ext cx="3652823" cy="369332"/>
+            </a:xfrm>
+            <a:prstGeom prst="rect">
+              <a:avLst/>
+            </a:prstGeom>
+            <a:noFill/>
+          </p:spPr>
+          <p:txBody>
+            <a:bodyPr wrap="square" rtlCol="0">
+              <a:spAutoFit/>
+            </a:bodyPr>
+            <a:lstStyle/>
+            <a:p>
+              <a:r>
+                <a:rPr lang="en-US" dirty="0"/>
+                <a:t>01-01-2008</a:t>
+              </a:r>
+              <a:endParaRPr lang="en-DE" dirty="0"/>
+            </a:p>
+          </p:txBody>
+        </p:sp>
+      </p:grpSp>
+      <p:pic>
+        <p:nvPicPr>
+          <p:cNvPr id="17" name="Picture 16">
+            <a:extLst>
+              <a:ext uri="{FF2B5EF4-FFF2-40B4-BE49-F238E27FC236}">
+                <a16:creationId xmlns:a16="http://schemas.microsoft.com/office/drawing/2014/main" id="{C5385869-BF99-B32F-1CF9-515EE307938E}"/>
+              </a:ext>
+            </a:extLst>
+          </p:cNvPr>
+          <p:cNvPicPr>
+            <a:picLocks noChangeAspect="1"/>
+          </p:cNvPicPr>
+          <p:nvPr/>
+        </p:nvPicPr>
+        <p:blipFill>
+          <a:blip r:embed="rId5"/>
+          <a:stretch>
+            <a:fillRect/>
+          </a:stretch>
+        </p:blipFill>
+        <p:spPr>
+          <a:xfrm>
+            <a:off x="889059" y="8532816"/>
+            <a:ext cx="9906682" cy="554833"/>
+          </a:xfrm>
+          <a:prstGeom prst="rect">
+            <a:avLst/>
+          </a:prstGeom>
+        </p:spPr>
+      </p:pic>
+      <p:pic>
+        <p:nvPicPr>
+          <p:cNvPr id="19" name="Picture 18">
+            <a:extLst>
+              <a:ext uri="{FF2B5EF4-FFF2-40B4-BE49-F238E27FC236}">
+                <a16:creationId xmlns:a16="http://schemas.microsoft.com/office/drawing/2014/main" id="{909E7157-7074-DA10-AC12-896390BAA993}"/>
+              </a:ext>
+            </a:extLst>
+          </p:cNvPr>
+          <p:cNvPicPr>
+            <a:picLocks noChangeAspect="1"/>
+          </p:cNvPicPr>
+          <p:nvPr/>
+        </p:nvPicPr>
+        <p:blipFill>
+          <a:blip r:embed="rId6"/>
+          <a:stretch>
+            <a:fillRect/>
+          </a:stretch>
+        </p:blipFill>
+        <p:spPr>
+          <a:xfrm>
+            <a:off x="993025" y="4219575"/>
+            <a:ext cx="8067675" cy="1076325"/>
+          </a:xfrm>
+          <a:prstGeom prst="rect">
+            <a:avLst/>
+          </a:prstGeom>
+        </p:spPr>
+      </p:pic>
+      <p:pic>
+        <p:nvPicPr>
+          <p:cNvPr id="32" name="Picture 31">
+            <a:extLst>
+              <a:ext uri="{FF2B5EF4-FFF2-40B4-BE49-F238E27FC236}">
+                <a16:creationId xmlns:a16="http://schemas.microsoft.com/office/drawing/2014/main" id="{DDFF0CDC-D203-1147-9E9D-BD285DCA1470}"/>
+              </a:ext>
+            </a:extLst>
+          </p:cNvPr>
+          <p:cNvPicPr>
+            <a:picLocks noChangeAspect="1"/>
+          </p:cNvPicPr>
+          <p:nvPr/>
+        </p:nvPicPr>
+        <p:blipFill>
+          <a:blip r:embed="rId7"/>
+          <a:stretch>
+            <a:fillRect/>
+          </a:stretch>
+        </p:blipFill>
+        <p:spPr>
+          <a:xfrm>
+            <a:off x="993025" y="2550309"/>
+            <a:ext cx="5991225" cy="1581150"/>
+          </a:xfrm>
+          <a:prstGeom prst="rect">
+            <a:avLst/>
+          </a:prstGeom>
+        </p:spPr>
+      </p:pic>
     </p:spTree>
     <p:extLst>
       <p:ext uri="{BB962C8B-B14F-4D97-AF65-F5344CB8AC3E}">

</xml_diff>